<commit_message>
Add slides 06-08: promotion gap, exit timing, and manager watch-list
Three new deep-dive slides appended to board deck: promotion gap as primary voluntary exit driver, September spike + 12-month engagement trajectory, and 3-year manager engagement decay trend with watch-list summary table.

https://claude.ai/code/session_015N2uXUkBbov28bBsUfALdd
</commit_message>
<xml_diff>
--- a/meridian_board_deck.pptx
+++ b/meridian_board_deck.pptx
@@ -11,6 +11,9 @@
     <p:sldId id="259" r:id="rId10"/>
     <p:sldId id="260" r:id="rId11"/>
     <p:sldId id="261" r:id="rId12"/>
+    <p:sldId id="262" r:id="rId13"/>
+    <p:sldId id="263" r:id="rId14"/>
+    <p:sldId id="264" r:id="rId15"/>
   </p:sldIdLst>
   <p:sldSz cx="12188952" cy="6858000" type="screen4x3"/>
   <p:notesSz cx="6858000" cy="9144000"/>
@@ -7588,6 +7591,3038 @@
                 </a:solidFill>
               </a:rPr>
               <a:t>Data source: Meridian HRIS snapshot (synthetic)  ·  Prepared by CPO Office  ·  April 2026</a:t>
+            </a:r>
+          </a:p>
+        </p:txBody>
+      </p:sp>
+    </p:spTree>
+  </p:cSld>
+  <p:clrMapOvr>
+    <a:masterClrMapping/>
+  </p:clrMapOvr>
+</p:sld>
+</file>
+
+<file path=ppt/slides/slide7.xml><?xml version="1.0" encoding="utf-8"?>
+<p:sld xmlns:a="http://schemas.openxmlformats.org/drawingml/2006/main" xmlns:p="http://schemas.openxmlformats.org/presentationml/2006/main" xmlns:r="http://schemas.openxmlformats.org/officeDocument/2006/relationships">
+  <p:cSld>
+    <p:spTree>
+      <p:nvGrpSpPr>
+        <p:cNvPr id="1" name=""/>
+        <p:cNvGrpSpPr/>
+        <p:nvPr/>
+      </p:nvGrpSpPr>
+      <p:grpSpPr/>
+      <p:sp>
+        <p:nvSpPr>
+          <p:cNvPr id="2" name="Rectangle 1"/>
+          <p:cNvSpPr/>
+          <p:nvPr/>
+        </p:nvSpPr>
+        <p:spPr>
+          <a:xfrm>
+            <a:off x="0" y="0"/>
+            <a:ext cx="12188952" cy="6858000"/>
+          </a:xfrm>
+          <a:prstGeom prst="rect">
+            <a:avLst/>
+          </a:prstGeom>
+          <a:solidFill>
+            <a:srgbClr val="F4F6F7"/>
+          </a:solidFill>
+          <a:ln>
+            <a:noFill/>
+          </a:ln>
+        </p:spPr>
+        <p:style>
+          <a:lnRef idx="1">
+            <a:schemeClr val="accent1"/>
+          </a:lnRef>
+          <a:fillRef idx="3">
+            <a:schemeClr val="accent1"/>
+          </a:fillRef>
+          <a:effectRef idx="2">
+            <a:schemeClr val="accent1"/>
+          </a:effectRef>
+          <a:fontRef idx="minor">
+            <a:schemeClr val="lt1"/>
+          </a:fontRef>
+        </p:style>
+        <p:txBody>
+          <a:bodyPr rtlCol="0" anchor="ctr"/>
+          <a:lstStyle/>
+          <a:p>
+            <a:pPr algn="ctr"/>
+          </a:p>
+        </p:txBody>
+      </p:sp>
+      <p:sp>
+        <p:nvSpPr>
+          <p:cNvPr id="3" name="Rectangle 2"/>
+          <p:cNvSpPr/>
+          <p:nvPr/>
+        </p:nvSpPr>
+        <p:spPr>
+          <a:xfrm>
+            <a:off x="0" y="0"/>
+            <a:ext cx="12188952" cy="1005840"/>
+          </a:xfrm>
+          <a:prstGeom prst="rect">
+            <a:avLst/>
+          </a:prstGeom>
+          <a:solidFill>
+            <a:srgbClr val="1B2A4A"/>
+          </a:solidFill>
+          <a:ln>
+            <a:noFill/>
+          </a:ln>
+        </p:spPr>
+        <p:style>
+          <a:lnRef idx="1">
+            <a:schemeClr val="accent1"/>
+          </a:lnRef>
+          <a:fillRef idx="3">
+            <a:schemeClr val="accent1"/>
+          </a:fillRef>
+          <a:effectRef idx="2">
+            <a:schemeClr val="accent1"/>
+          </a:effectRef>
+          <a:fontRef idx="minor">
+            <a:schemeClr val="lt1"/>
+          </a:fontRef>
+        </p:style>
+        <p:txBody>
+          <a:bodyPr rtlCol="0" anchor="ctr"/>
+          <a:lstStyle/>
+          <a:p>
+            <a:pPr algn="ctr"/>
+          </a:p>
+        </p:txBody>
+      </p:sp>
+      <p:sp>
+        <p:nvSpPr>
+          <p:cNvPr id="4" name="Rectangle 3"/>
+          <p:cNvSpPr/>
+          <p:nvPr/>
+        </p:nvSpPr>
+        <p:spPr>
+          <a:xfrm>
+            <a:off x="0" y="1005840"/>
+            <a:ext cx="12188952" cy="54864"/>
+          </a:xfrm>
+          <a:prstGeom prst="rect">
+            <a:avLst/>
+          </a:prstGeom>
+          <a:solidFill>
+            <a:srgbClr val="C0392B"/>
+          </a:solidFill>
+          <a:ln>
+            <a:noFill/>
+          </a:ln>
+        </p:spPr>
+        <p:style>
+          <a:lnRef idx="1">
+            <a:schemeClr val="accent1"/>
+          </a:lnRef>
+          <a:fillRef idx="3">
+            <a:schemeClr val="accent1"/>
+          </a:fillRef>
+          <a:effectRef idx="2">
+            <a:schemeClr val="accent1"/>
+          </a:effectRef>
+          <a:fontRef idx="minor">
+            <a:schemeClr val="lt1"/>
+          </a:fontRef>
+        </p:style>
+        <p:txBody>
+          <a:bodyPr rtlCol="0" anchor="ctr"/>
+          <a:lstStyle/>
+          <a:p>
+            <a:pPr algn="ctr"/>
+          </a:p>
+        </p:txBody>
+      </p:sp>
+      <p:sp>
+        <p:nvSpPr>
+          <p:cNvPr id="5" name="TextBox 4"/>
+          <p:cNvSpPr txBox="1"/>
+          <p:nvPr/>
+        </p:nvSpPr>
+        <p:spPr>
+          <a:xfrm>
+            <a:off x="365760" y="228600"/>
+            <a:ext cx="10972800" cy="548640"/>
+          </a:xfrm>
+          <a:prstGeom prst="rect">
+            <a:avLst/>
+          </a:prstGeom>
+          <a:noFill/>
+        </p:spPr>
+        <p:txBody>
+          <a:bodyPr wrap="square">
+            <a:spAutoFit/>
+          </a:bodyPr>
+          <a:lstStyle/>
+          <a:p>
+            <a:pPr algn="l"/>
+            <a:r>
+              <a:rPr sz="2200" b="1">
+                <a:solidFill>
+                  <a:srgbClr val="FFFFFF"/>
+                </a:solidFill>
+              </a:rPr>
+              <a:t>06  |  DEEP DIVE:  PROMOTION IS THE MISSING LEVER</a:t>
+            </a:r>
+          </a:p>
+        </p:txBody>
+      </p:sp>
+      <p:sp>
+        <p:nvSpPr>
+          <p:cNvPr id="6" name="Rectangle 5"/>
+          <p:cNvSpPr/>
+          <p:nvPr/>
+        </p:nvSpPr>
+        <p:spPr>
+          <a:xfrm>
+            <a:off x="320040" y="1234440"/>
+            <a:ext cx="2651760" cy="1554480"/>
+          </a:xfrm>
+          <a:prstGeom prst="rect">
+            <a:avLst/>
+          </a:prstGeom>
+          <a:solidFill>
+            <a:srgbClr val="FFFFFF"/>
+          </a:solidFill>
+          <a:ln>
+            <a:noFill/>
+          </a:ln>
+        </p:spPr>
+        <p:style>
+          <a:lnRef idx="1">
+            <a:schemeClr val="accent1"/>
+          </a:lnRef>
+          <a:fillRef idx="3">
+            <a:schemeClr val="accent1"/>
+          </a:fillRef>
+          <a:effectRef idx="2">
+            <a:schemeClr val="accent1"/>
+          </a:effectRef>
+          <a:fontRef idx="minor">
+            <a:schemeClr val="lt1"/>
+          </a:fontRef>
+        </p:style>
+        <p:txBody>
+          <a:bodyPr rtlCol="0" anchor="ctr"/>
+          <a:lstStyle/>
+          <a:p>
+            <a:pPr algn="ctr"/>
+          </a:p>
+        </p:txBody>
+      </p:sp>
+      <p:sp>
+        <p:nvSpPr>
+          <p:cNvPr id="7" name="TextBox 6"/>
+          <p:cNvSpPr txBox="1"/>
+          <p:nvPr/>
+        </p:nvSpPr>
+        <p:spPr>
+          <a:xfrm>
+            <a:off x="457200" y="1298448"/>
+            <a:ext cx="2377440" cy="777240"/>
+          </a:xfrm>
+          <a:prstGeom prst="rect">
+            <a:avLst/>
+          </a:prstGeom>
+          <a:noFill/>
+        </p:spPr>
+        <p:txBody>
+          <a:bodyPr wrap="square">
+            <a:spAutoFit/>
+          </a:bodyPr>
+          <a:lstStyle/>
+          <a:p>
+            <a:pPr algn="l"/>
+            <a:r>
+              <a:rPr sz="5200" b="1">
+                <a:solidFill>
+                  <a:srgbClr val="C0392B"/>
+                </a:solidFill>
+              </a:rPr>
+              <a:t>3.5×</a:t>
+            </a:r>
+          </a:p>
+        </p:txBody>
+      </p:sp>
+      <p:sp>
+        <p:nvSpPr>
+          <p:cNvPr id="8" name="TextBox 7"/>
+          <p:cNvSpPr txBox="1"/>
+          <p:nvPr/>
+        </p:nvSpPr>
+        <p:spPr>
+          <a:xfrm>
+            <a:off x="457200" y="2011680"/>
+            <a:ext cx="2377440" cy="685800"/>
+          </a:xfrm>
+          <a:prstGeom prst="rect">
+            <a:avLst/>
+          </a:prstGeom>
+          <a:noFill/>
+        </p:spPr>
+        <p:txBody>
+          <a:bodyPr wrap="square">
+            <a:spAutoFit/>
+          </a:bodyPr>
+          <a:lstStyle/>
+          <a:p>
+            <a:pPr algn="l"/>
+            <a:r>
+              <a:rPr sz="1000" b="0">
+                <a:solidFill>
+                  <a:srgbClr val="2C3E50"/>
+                </a:solidFill>
+              </a:rPr>
+              <a:t>higher promotion rate
+for active vs. leavers
+(2–4 yr tenure band)</a:t>
+            </a:r>
+          </a:p>
+        </p:txBody>
+      </p:sp>
+      <p:sp>
+        <p:nvSpPr>
+          <p:cNvPr id="9" name="Rectangle 8"/>
+          <p:cNvSpPr/>
+          <p:nvPr/>
+        </p:nvSpPr>
+        <p:spPr>
+          <a:xfrm>
+            <a:off x="320040" y="2926080"/>
+            <a:ext cx="2651760" cy="1371600"/>
+          </a:xfrm>
+          <a:prstGeom prst="rect">
+            <a:avLst/>
+          </a:prstGeom>
+          <a:solidFill>
+            <a:srgbClr val="FFFFFF"/>
+          </a:solidFill>
+          <a:ln>
+            <a:noFill/>
+          </a:ln>
+        </p:spPr>
+        <p:style>
+          <a:lnRef idx="1">
+            <a:schemeClr val="accent1"/>
+          </a:lnRef>
+          <a:fillRef idx="3">
+            <a:schemeClr val="accent1"/>
+          </a:fillRef>
+          <a:effectRef idx="2">
+            <a:schemeClr val="accent1"/>
+          </a:effectRef>
+          <a:fontRef idx="minor">
+            <a:schemeClr val="lt1"/>
+          </a:fontRef>
+        </p:style>
+        <p:txBody>
+          <a:bodyPr rtlCol="0" anchor="ctr"/>
+          <a:lstStyle/>
+          <a:p>
+            <a:pPr algn="ctr"/>
+          </a:p>
+        </p:txBody>
+      </p:sp>
+      <p:sp>
+        <p:nvSpPr>
+          <p:cNvPr id="10" name="TextBox 9"/>
+          <p:cNvSpPr txBox="1"/>
+          <p:nvPr/>
+        </p:nvSpPr>
+        <p:spPr>
+          <a:xfrm>
+            <a:off x="457200" y="2990088"/>
+            <a:ext cx="2377440" cy="685800"/>
+          </a:xfrm>
+          <a:prstGeom prst="rect">
+            <a:avLst/>
+          </a:prstGeom>
+          <a:noFill/>
+        </p:spPr>
+        <p:txBody>
+          <a:bodyPr wrap="square">
+            <a:spAutoFit/>
+          </a:bodyPr>
+          <a:lstStyle/>
+          <a:p>
+            <a:pPr algn="l"/>
+            <a:r>
+              <a:rPr sz="4200" b="1">
+                <a:solidFill>
+                  <a:srgbClr val="C0392B"/>
+                </a:solidFill>
+              </a:rPr>
+              <a:t>7.3%</a:t>
+            </a:r>
+          </a:p>
+        </p:txBody>
+      </p:sp>
+      <p:sp>
+        <p:nvSpPr>
+          <p:cNvPr id="11" name="TextBox 10"/>
+          <p:cNvSpPr txBox="1"/>
+          <p:nvPr/>
+        </p:nvSpPr>
+        <p:spPr>
+          <a:xfrm>
+            <a:off x="457200" y="3611880"/>
+            <a:ext cx="2377440" cy="640080"/>
+          </a:xfrm>
+          <a:prstGeom prst="rect">
+            <a:avLst/>
+          </a:prstGeom>
+          <a:noFill/>
+        </p:spPr>
+        <p:txBody>
+          <a:bodyPr wrap="square">
+            <a:spAutoFit/>
+          </a:bodyPr>
+          <a:lstStyle/>
+          <a:p>
+            <a:pPr algn="l"/>
+            <a:r>
+              <a:rPr sz="1000" b="0">
+                <a:solidFill>
+                  <a:srgbClr val="2C3E50"/>
+                </a:solidFill>
+              </a:rPr>
+              <a:t>of voluntary leavers
+ever promoted
+(vs 20% of active staff)</a:t>
+            </a:r>
+          </a:p>
+        </p:txBody>
+      </p:sp>
+      <p:sp>
+        <p:nvSpPr>
+          <p:cNvPr id="12" name="Rectangle 11"/>
+          <p:cNvSpPr/>
+          <p:nvPr/>
+        </p:nvSpPr>
+        <p:spPr>
+          <a:xfrm>
+            <a:off x="320040" y="4434840"/>
+            <a:ext cx="2651760" cy="1280160"/>
+          </a:xfrm>
+          <a:prstGeom prst="rect">
+            <a:avLst/>
+          </a:prstGeom>
+          <a:solidFill>
+            <a:srgbClr val="FFFFFF"/>
+          </a:solidFill>
+          <a:ln>
+            <a:noFill/>
+          </a:ln>
+        </p:spPr>
+        <p:style>
+          <a:lnRef idx="1">
+            <a:schemeClr val="accent1"/>
+          </a:lnRef>
+          <a:fillRef idx="3">
+            <a:schemeClr val="accent1"/>
+          </a:fillRef>
+          <a:effectRef idx="2">
+            <a:schemeClr val="accent1"/>
+          </a:effectRef>
+          <a:fontRef idx="minor">
+            <a:schemeClr val="lt1"/>
+          </a:fontRef>
+        </p:style>
+        <p:txBody>
+          <a:bodyPr rtlCol="0" anchor="ctr"/>
+          <a:lstStyle/>
+          <a:p>
+            <a:pPr algn="ctr"/>
+          </a:p>
+        </p:txBody>
+      </p:sp>
+      <p:sp>
+        <p:nvSpPr>
+          <p:cNvPr id="13" name="TextBox 12"/>
+          <p:cNvSpPr txBox="1"/>
+          <p:nvPr/>
+        </p:nvSpPr>
+        <p:spPr>
+          <a:xfrm>
+            <a:off x="457200" y="4498848"/>
+            <a:ext cx="2377440" cy="457200"/>
+          </a:xfrm>
+          <a:prstGeom prst="rect">
+            <a:avLst/>
+          </a:prstGeom>
+          <a:noFill/>
+        </p:spPr>
+        <p:txBody>
+          <a:bodyPr wrap="square">
+            <a:spAutoFit/>
+          </a:bodyPr>
+          <a:lstStyle/>
+          <a:p>
+            <a:pPr algn="l"/>
+            <a:r>
+              <a:rPr sz="1600" b="1">
+                <a:solidFill>
+                  <a:srgbClr val="E67E22"/>
+                </a:solidFill>
+              </a:rPr>
+              <a:t>All tenures</a:t>
+            </a:r>
+          </a:p>
+        </p:txBody>
+      </p:sp>
+      <p:sp>
+        <p:nvSpPr>
+          <p:cNvPr id="14" name="TextBox 13"/>
+          <p:cNvSpPr txBox="1"/>
+          <p:nvPr/>
+        </p:nvSpPr>
+        <p:spPr>
+          <a:xfrm>
+            <a:off x="457200" y="4937760"/>
+            <a:ext cx="2377440" cy="685800"/>
+          </a:xfrm>
+          <a:prstGeom prst="rect">
+            <a:avLst/>
+          </a:prstGeom>
+          <a:noFill/>
+        </p:spPr>
+        <p:txBody>
+          <a:bodyPr wrap="square">
+            <a:spAutoFit/>
+          </a:bodyPr>
+          <a:lstStyle/>
+          <a:p>
+            <a:pPr algn="l"/>
+            <a:r>
+              <a:rPr sz="1000" b="0">
+                <a:solidFill>
+                  <a:srgbClr val="2C3E50"/>
+                </a:solidFill>
+              </a:rPr>
+              <a:t>Promotion gap holds
+at every tenure band
+— it's systemic, not
+a new-hire problem</a:t>
+            </a:r>
+          </a:p>
+        </p:txBody>
+      </p:sp>
+      <p:pic>
+        <p:nvPicPr>
+          <p:cNvPr id="15" name="Picture 14" descr="image.png"/>
+          <p:cNvPicPr>
+            <a:picLocks noChangeAspect="1"/>
+          </p:cNvPicPr>
+          <p:nvPr/>
+        </p:nvPicPr>
+        <p:blipFill>
+          <a:blip r:embed="rId2"/>
+          <a:stretch>
+            <a:fillRect/>
+          </a:stretch>
+        </p:blipFill>
+        <p:spPr>
+          <a:xfrm>
+            <a:off x="3246120" y="1234440"/>
+            <a:ext cx="5486400" cy="4206240"/>
+          </a:xfrm>
+          <a:prstGeom prst="rect">
+            <a:avLst/>
+          </a:prstGeom>
+        </p:spPr>
+      </p:pic>
+      <p:sp>
+        <p:nvSpPr>
+          <p:cNvPr id="16" name="Rectangle 15"/>
+          <p:cNvSpPr/>
+          <p:nvPr/>
+        </p:nvSpPr>
+        <p:spPr>
+          <a:xfrm>
+            <a:off x="8961120" y="1234440"/>
+            <a:ext cx="2926080" cy="4206240"/>
+          </a:xfrm>
+          <a:prstGeom prst="rect">
+            <a:avLst/>
+          </a:prstGeom>
+          <a:solidFill>
+            <a:srgbClr val="FFF5F5"/>
+          </a:solidFill>
+          <a:ln>
+            <a:noFill/>
+          </a:ln>
+        </p:spPr>
+        <p:style>
+          <a:lnRef idx="1">
+            <a:schemeClr val="accent1"/>
+          </a:lnRef>
+          <a:fillRef idx="3">
+            <a:schemeClr val="accent1"/>
+          </a:fillRef>
+          <a:effectRef idx="2">
+            <a:schemeClr val="accent1"/>
+          </a:effectRef>
+          <a:fontRef idx="minor">
+            <a:schemeClr val="lt1"/>
+          </a:fontRef>
+        </p:style>
+        <p:txBody>
+          <a:bodyPr rtlCol="0" anchor="ctr"/>
+          <a:lstStyle/>
+          <a:p>
+            <a:pPr algn="ctr"/>
+          </a:p>
+        </p:txBody>
+      </p:sp>
+      <p:sp>
+        <p:nvSpPr>
+          <p:cNvPr id="17" name="TextBox 16"/>
+          <p:cNvSpPr txBox="1"/>
+          <p:nvPr/>
+        </p:nvSpPr>
+        <p:spPr>
+          <a:xfrm>
+            <a:off x="9098280" y="1371600"/>
+            <a:ext cx="2651760" cy="365760"/>
+          </a:xfrm>
+          <a:prstGeom prst="rect">
+            <a:avLst/>
+          </a:prstGeom>
+          <a:noFill/>
+        </p:spPr>
+        <p:txBody>
+          <a:bodyPr wrap="square">
+            <a:spAutoFit/>
+          </a:bodyPr>
+          <a:lstStyle/>
+          <a:p>
+            <a:pPr algn="l"/>
+            <a:r>
+              <a:rPr sz="900" b="1">
+                <a:solidFill>
+                  <a:srgbClr val="C0392B"/>
+                </a:solidFill>
+              </a:rPr>
+              <a:t>KEY IMPLICATIONS</a:t>
+            </a:r>
+          </a:p>
+        </p:txBody>
+      </p:sp>
+      <p:sp>
+        <p:nvSpPr>
+          <p:cNvPr id="18" name="TextBox 17"/>
+          <p:cNvSpPr txBox="1"/>
+          <p:nvPr/>
+        </p:nvSpPr>
+        <p:spPr>
+          <a:xfrm>
+            <a:off x="9098280" y="1828800"/>
+            <a:ext cx="2651760" cy="868680"/>
+          </a:xfrm>
+          <a:prstGeom prst="rect">
+            <a:avLst/>
+          </a:prstGeom>
+          <a:noFill/>
+        </p:spPr>
+        <p:txBody>
+          <a:bodyPr wrap="square">
+            <a:spAutoFit/>
+          </a:bodyPr>
+          <a:lstStyle/>
+          <a:p>
+            <a:pPr algn="l"/>
+            <a:r>
+              <a:rPr sz="950" b="0">
+                <a:solidFill>
+                  <a:srgbClr val="2C3E50"/>
+                </a:solidFill>
+              </a:rPr>
+              <a:t>› Career stagnation — not pay — is the primary voluntary exit trigger</a:t>
+            </a:r>
+          </a:p>
+        </p:txBody>
+      </p:sp>
+      <p:sp>
+        <p:nvSpPr>
+          <p:cNvPr id="19" name="TextBox 18"/>
+          <p:cNvSpPr txBox="1"/>
+          <p:nvPr/>
+        </p:nvSpPr>
+        <p:spPr>
+          <a:xfrm>
+            <a:off x="9098280" y="2788920"/>
+            <a:ext cx="2651760" cy="868680"/>
+          </a:xfrm>
+          <a:prstGeom prst="rect">
+            <a:avLst/>
+          </a:prstGeom>
+          <a:noFill/>
+        </p:spPr>
+        <p:txBody>
+          <a:bodyPr wrap="square">
+            <a:spAutoFit/>
+          </a:bodyPr>
+          <a:lstStyle/>
+          <a:p>
+            <a:pPr algn="l"/>
+            <a:r>
+              <a:rPr sz="950" b="0">
+                <a:solidFill>
+                  <a:srgbClr val="2C3E50"/>
+                </a:solidFill>
+              </a:rPr>
+              <a:t>› Fixing promo velocity in Product &amp; CS would directly cut 24–26% attrition</a:t>
+            </a:r>
+          </a:p>
+        </p:txBody>
+      </p:sp>
+      <p:sp>
+        <p:nvSpPr>
+          <p:cNvPr id="20" name="TextBox 19"/>
+          <p:cNvSpPr txBox="1"/>
+          <p:nvPr/>
+        </p:nvSpPr>
+        <p:spPr>
+          <a:xfrm>
+            <a:off x="9098280" y="3749040"/>
+            <a:ext cx="2651760" cy="868680"/>
+          </a:xfrm>
+          <a:prstGeom prst="rect">
+            <a:avLst/>
+          </a:prstGeom>
+          <a:noFill/>
+        </p:spPr>
+        <p:txBody>
+          <a:bodyPr wrap="square">
+            <a:spAutoFit/>
+          </a:bodyPr>
+          <a:lstStyle/>
+          <a:p>
+            <a:pPr algn="l"/>
+            <a:r>
+              <a:rPr sz="950" b="0">
+                <a:solidFill>
+                  <a:srgbClr val="2C3E50"/>
+                </a:solidFill>
+              </a:rPr>
+              <a:t>› Proposed action: bi-annual promo windows with manager accountability metrics</a:t>
+            </a:r>
+          </a:p>
+        </p:txBody>
+      </p:sp>
+    </p:spTree>
+  </p:cSld>
+  <p:clrMapOvr>
+    <a:masterClrMapping/>
+  </p:clrMapOvr>
+</p:sld>
+</file>
+
+<file path=ppt/slides/slide8.xml><?xml version="1.0" encoding="utf-8"?>
+<p:sld xmlns:a="http://schemas.openxmlformats.org/drawingml/2006/main" xmlns:p="http://schemas.openxmlformats.org/presentationml/2006/main" xmlns:r="http://schemas.openxmlformats.org/officeDocument/2006/relationships">
+  <p:cSld>
+    <p:spTree>
+      <p:nvGrpSpPr>
+        <p:cNvPr id="1" name=""/>
+        <p:cNvGrpSpPr/>
+        <p:nvPr/>
+      </p:nvGrpSpPr>
+      <p:grpSpPr/>
+      <p:sp>
+        <p:nvSpPr>
+          <p:cNvPr id="2" name="Rectangle 1"/>
+          <p:cNvSpPr/>
+          <p:nvPr/>
+        </p:nvSpPr>
+        <p:spPr>
+          <a:xfrm>
+            <a:off x="0" y="0"/>
+            <a:ext cx="12188952" cy="6858000"/>
+          </a:xfrm>
+          <a:prstGeom prst="rect">
+            <a:avLst/>
+          </a:prstGeom>
+          <a:solidFill>
+            <a:srgbClr val="F4F6F7"/>
+          </a:solidFill>
+          <a:ln>
+            <a:noFill/>
+          </a:ln>
+        </p:spPr>
+        <p:style>
+          <a:lnRef idx="1">
+            <a:schemeClr val="accent1"/>
+          </a:lnRef>
+          <a:fillRef idx="3">
+            <a:schemeClr val="accent1"/>
+          </a:fillRef>
+          <a:effectRef idx="2">
+            <a:schemeClr val="accent1"/>
+          </a:effectRef>
+          <a:fontRef idx="minor">
+            <a:schemeClr val="lt1"/>
+          </a:fontRef>
+        </p:style>
+        <p:txBody>
+          <a:bodyPr rtlCol="0" anchor="ctr"/>
+          <a:lstStyle/>
+          <a:p>
+            <a:pPr algn="ctr"/>
+          </a:p>
+        </p:txBody>
+      </p:sp>
+      <p:sp>
+        <p:nvSpPr>
+          <p:cNvPr id="3" name="Rectangle 2"/>
+          <p:cNvSpPr/>
+          <p:nvPr/>
+        </p:nvSpPr>
+        <p:spPr>
+          <a:xfrm>
+            <a:off x="0" y="0"/>
+            <a:ext cx="12188952" cy="1005840"/>
+          </a:xfrm>
+          <a:prstGeom prst="rect">
+            <a:avLst/>
+          </a:prstGeom>
+          <a:solidFill>
+            <a:srgbClr val="1B2A4A"/>
+          </a:solidFill>
+          <a:ln>
+            <a:noFill/>
+          </a:ln>
+        </p:spPr>
+        <p:style>
+          <a:lnRef idx="1">
+            <a:schemeClr val="accent1"/>
+          </a:lnRef>
+          <a:fillRef idx="3">
+            <a:schemeClr val="accent1"/>
+          </a:fillRef>
+          <a:effectRef idx="2">
+            <a:schemeClr val="accent1"/>
+          </a:effectRef>
+          <a:fontRef idx="minor">
+            <a:schemeClr val="lt1"/>
+          </a:fontRef>
+        </p:style>
+        <p:txBody>
+          <a:bodyPr rtlCol="0" anchor="ctr"/>
+          <a:lstStyle/>
+          <a:p>
+            <a:pPr algn="ctr"/>
+          </a:p>
+        </p:txBody>
+      </p:sp>
+      <p:sp>
+        <p:nvSpPr>
+          <p:cNvPr id="4" name="Rectangle 3"/>
+          <p:cNvSpPr/>
+          <p:nvPr/>
+        </p:nvSpPr>
+        <p:spPr>
+          <a:xfrm>
+            <a:off x="0" y="1005840"/>
+            <a:ext cx="12188952" cy="54864"/>
+          </a:xfrm>
+          <a:prstGeom prst="rect">
+            <a:avLst/>
+          </a:prstGeom>
+          <a:solidFill>
+            <a:srgbClr val="C0392B"/>
+          </a:solidFill>
+          <a:ln>
+            <a:noFill/>
+          </a:ln>
+        </p:spPr>
+        <p:style>
+          <a:lnRef idx="1">
+            <a:schemeClr val="accent1"/>
+          </a:lnRef>
+          <a:fillRef idx="3">
+            <a:schemeClr val="accent1"/>
+          </a:fillRef>
+          <a:effectRef idx="2">
+            <a:schemeClr val="accent1"/>
+          </a:effectRef>
+          <a:fontRef idx="minor">
+            <a:schemeClr val="lt1"/>
+          </a:fontRef>
+        </p:style>
+        <p:txBody>
+          <a:bodyPr rtlCol="0" anchor="ctr"/>
+          <a:lstStyle/>
+          <a:p>
+            <a:pPr algn="ctr"/>
+          </a:p>
+        </p:txBody>
+      </p:sp>
+      <p:sp>
+        <p:nvSpPr>
+          <p:cNvPr id="5" name="TextBox 4"/>
+          <p:cNvSpPr txBox="1"/>
+          <p:nvPr/>
+        </p:nvSpPr>
+        <p:spPr>
+          <a:xfrm>
+            <a:off x="365760" y="228600"/>
+            <a:ext cx="10972800" cy="548640"/>
+          </a:xfrm>
+          <a:prstGeom prst="rect">
+            <a:avLst/>
+          </a:prstGeom>
+          <a:noFill/>
+        </p:spPr>
+        <p:txBody>
+          <a:bodyPr wrap="square">
+            <a:spAutoFit/>
+          </a:bodyPr>
+          <a:lstStyle/>
+          <a:p>
+            <a:pPr algn="l"/>
+            <a:r>
+              <a:rPr sz="2200" b="1">
+                <a:solidFill>
+                  <a:srgbClr val="FFFFFF"/>
+                </a:solidFill>
+              </a:rPr>
+              <a:t>07  |  DEEP DIVE:  WHEN AND HOW PEOPLE DISENGAGE</a:t>
+            </a:r>
+          </a:p>
+        </p:txBody>
+      </p:sp>
+      <p:pic>
+        <p:nvPicPr>
+          <p:cNvPr id="6" name="Picture 5" descr="image.png"/>
+          <p:cNvPicPr>
+            <a:picLocks noChangeAspect="1"/>
+          </p:cNvPicPr>
+          <p:nvPr/>
+        </p:nvPicPr>
+        <p:blipFill>
+          <a:blip r:embed="rId2"/>
+          <a:stretch>
+            <a:fillRect/>
+          </a:stretch>
+        </p:blipFill>
+        <p:spPr>
+          <a:xfrm>
+            <a:off x="320040" y="1234440"/>
+            <a:ext cx="5303520" cy="3840480"/>
+          </a:xfrm>
+          <a:prstGeom prst="rect">
+            <a:avLst/>
+          </a:prstGeom>
+        </p:spPr>
+      </p:pic>
+      <p:pic>
+        <p:nvPicPr>
+          <p:cNvPr id="7" name="Picture 6" descr="image.png"/>
+          <p:cNvPicPr>
+            <a:picLocks noChangeAspect="1"/>
+          </p:cNvPicPr>
+          <p:nvPr/>
+        </p:nvPicPr>
+        <p:blipFill>
+          <a:blip r:embed="rId3"/>
+          <a:stretch>
+            <a:fillRect/>
+          </a:stretch>
+        </p:blipFill>
+        <p:spPr>
+          <a:xfrm>
+            <a:off x="5989320" y="1234440"/>
+            <a:ext cx="5303520" cy="3840480"/>
+          </a:xfrm>
+          <a:prstGeom prst="rect">
+            <a:avLst/>
+          </a:prstGeom>
+        </p:spPr>
+      </p:pic>
+      <p:sp>
+        <p:nvSpPr>
+          <p:cNvPr id="8" name="Rectangle 7"/>
+          <p:cNvSpPr/>
+          <p:nvPr/>
+        </p:nvSpPr>
+        <p:spPr>
+          <a:xfrm>
+            <a:off x="320040" y="5257800"/>
+            <a:ext cx="5303520" cy="1280160"/>
+          </a:xfrm>
+          <a:prstGeom prst="rect">
+            <a:avLst/>
+          </a:prstGeom>
+          <a:solidFill>
+            <a:srgbClr val="FFF5F5"/>
+          </a:solidFill>
+          <a:ln>
+            <a:noFill/>
+          </a:ln>
+        </p:spPr>
+        <p:style>
+          <a:lnRef idx="1">
+            <a:schemeClr val="accent1"/>
+          </a:lnRef>
+          <a:fillRef idx="3">
+            <a:schemeClr val="accent1"/>
+          </a:fillRef>
+          <a:effectRef idx="2">
+            <a:schemeClr val="accent1"/>
+          </a:effectRef>
+          <a:fontRef idx="minor">
+            <a:schemeClr val="lt1"/>
+          </a:fontRef>
+        </p:style>
+        <p:txBody>
+          <a:bodyPr rtlCol="0" anchor="ctr"/>
+          <a:lstStyle/>
+          <a:p>
+            <a:pPr algn="ctr"/>
+          </a:p>
+        </p:txBody>
+      </p:sp>
+      <p:sp>
+        <p:nvSpPr>
+          <p:cNvPr id="9" name="TextBox 8"/>
+          <p:cNvSpPr txBox="1"/>
+          <p:nvPr/>
+        </p:nvSpPr>
+        <p:spPr>
+          <a:xfrm>
+            <a:off x="457200" y="5321808"/>
+            <a:ext cx="5029200" cy="1143000"/>
+          </a:xfrm>
+          <a:prstGeom prst="rect">
+            <a:avLst/>
+          </a:prstGeom>
+          <a:noFill/>
+        </p:spPr>
+        <p:txBody>
+          <a:bodyPr wrap="square">
+            <a:spAutoFit/>
+          </a:bodyPr>
+          <a:lstStyle/>
+          <a:p>
+            <a:pPr algn="l"/>
+            <a:r>
+              <a:rPr sz="950" b="0">
+                <a:solidFill>
+                  <a:srgbClr val="2C3E50"/>
+                </a:solidFill>
+              </a:rPr>
+              <a:t>› September has 45 exits — 40% above monthly average.  Engineering alone accounts for 38%.  Timing is consistent with mid-year review outcomes triggering resignation decisions.</a:t>
+            </a:r>
+          </a:p>
+        </p:txBody>
+      </p:sp>
+      <p:sp>
+        <p:nvSpPr>
+          <p:cNvPr id="10" name="Rectangle 9"/>
+          <p:cNvSpPr/>
+          <p:nvPr/>
+        </p:nvSpPr>
+        <p:spPr>
+          <a:xfrm>
+            <a:off x="5989320" y="5257800"/>
+            <a:ext cx="5303520" cy="1280160"/>
+          </a:xfrm>
+          <a:prstGeom prst="rect">
+            <a:avLst/>
+          </a:prstGeom>
+          <a:solidFill>
+            <a:srgbClr val="FFF5F5"/>
+          </a:solidFill>
+          <a:ln>
+            <a:noFill/>
+          </a:ln>
+        </p:spPr>
+        <p:style>
+          <a:lnRef idx="1">
+            <a:schemeClr val="accent1"/>
+          </a:lnRef>
+          <a:fillRef idx="3">
+            <a:schemeClr val="accent1"/>
+          </a:fillRef>
+          <a:effectRef idx="2">
+            <a:schemeClr val="accent1"/>
+          </a:effectRef>
+          <a:fontRef idx="minor">
+            <a:schemeClr val="lt1"/>
+          </a:fontRef>
+        </p:style>
+        <p:txBody>
+          <a:bodyPr rtlCol="0" anchor="ctr"/>
+          <a:lstStyle/>
+          <a:p>
+            <a:pPr algn="ctr"/>
+          </a:p>
+        </p:txBody>
+      </p:sp>
+      <p:sp>
+        <p:nvSpPr>
+          <p:cNvPr id="11" name="TextBox 10"/>
+          <p:cNvSpPr txBox="1"/>
+          <p:nvPr/>
+        </p:nvSpPr>
+        <p:spPr>
+          <a:xfrm>
+            <a:off x="6126480" y="5321808"/>
+            <a:ext cx="5029200" cy="1143000"/>
+          </a:xfrm>
+          <a:prstGeom prst="rect">
+            <a:avLst/>
+          </a:prstGeom>
+          <a:noFill/>
+        </p:spPr>
+        <p:txBody>
+          <a:bodyPr wrap="square">
+            <a:spAutoFit/>
+          </a:bodyPr>
+          <a:lstStyle/>
+          <a:p>
+            <a:pPr algn="l"/>
+            <a:r>
+              <a:rPr sz="950" b="0">
+                <a:solidFill>
+                  <a:srgbClr val="2C3E50"/>
+                </a:solidFill>
+              </a:rPr>
+              <a:t>› Leavers sit 0.35 points below active employees for the entire year before they exit.  Exit interviews are too late — pulse scores at 12 months out are the real early-warning signal.</a:t>
+            </a:r>
+          </a:p>
+        </p:txBody>
+      </p:sp>
+    </p:spTree>
+  </p:cSld>
+  <p:clrMapOvr>
+    <a:masterClrMapping/>
+  </p:clrMapOvr>
+</p:sld>
+</file>
+
+<file path=ppt/slides/slide9.xml><?xml version="1.0" encoding="utf-8"?>
+<p:sld xmlns:a="http://schemas.openxmlformats.org/drawingml/2006/main" xmlns:p="http://schemas.openxmlformats.org/presentationml/2006/main" xmlns:r="http://schemas.openxmlformats.org/officeDocument/2006/relationships">
+  <p:cSld>
+    <p:spTree>
+      <p:nvGrpSpPr>
+        <p:cNvPr id="1" name=""/>
+        <p:cNvGrpSpPr/>
+        <p:nvPr/>
+      </p:nvGrpSpPr>
+      <p:grpSpPr/>
+      <p:sp>
+        <p:nvSpPr>
+          <p:cNvPr id="2" name="Rectangle 1"/>
+          <p:cNvSpPr/>
+          <p:nvPr/>
+        </p:nvSpPr>
+        <p:spPr>
+          <a:xfrm>
+            <a:off x="0" y="0"/>
+            <a:ext cx="12188952" cy="6858000"/>
+          </a:xfrm>
+          <a:prstGeom prst="rect">
+            <a:avLst/>
+          </a:prstGeom>
+          <a:solidFill>
+            <a:srgbClr val="F4F6F7"/>
+          </a:solidFill>
+          <a:ln>
+            <a:noFill/>
+          </a:ln>
+        </p:spPr>
+        <p:style>
+          <a:lnRef idx="1">
+            <a:schemeClr val="accent1"/>
+          </a:lnRef>
+          <a:fillRef idx="3">
+            <a:schemeClr val="accent1"/>
+          </a:fillRef>
+          <a:effectRef idx="2">
+            <a:schemeClr val="accent1"/>
+          </a:effectRef>
+          <a:fontRef idx="minor">
+            <a:schemeClr val="lt1"/>
+          </a:fontRef>
+        </p:style>
+        <p:txBody>
+          <a:bodyPr rtlCol="0" anchor="ctr"/>
+          <a:lstStyle/>
+          <a:p>
+            <a:pPr algn="ctr"/>
+          </a:p>
+        </p:txBody>
+      </p:sp>
+      <p:sp>
+        <p:nvSpPr>
+          <p:cNvPr id="3" name="Rectangle 2"/>
+          <p:cNvSpPr/>
+          <p:nvPr/>
+        </p:nvSpPr>
+        <p:spPr>
+          <a:xfrm>
+            <a:off x="0" y="0"/>
+            <a:ext cx="12188952" cy="1005840"/>
+          </a:xfrm>
+          <a:prstGeom prst="rect">
+            <a:avLst/>
+          </a:prstGeom>
+          <a:solidFill>
+            <a:srgbClr val="1B2A4A"/>
+          </a:solidFill>
+          <a:ln>
+            <a:noFill/>
+          </a:ln>
+        </p:spPr>
+        <p:style>
+          <a:lnRef idx="1">
+            <a:schemeClr val="accent1"/>
+          </a:lnRef>
+          <a:fillRef idx="3">
+            <a:schemeClr val="accent1"/>
+          </a:fillRef>
+          <a:effectRef idx="2">
+            <a:schemeClr val="accent1"/>
+          </a:effectRef>
+          <a:fontRef idx="minor">
+            <a:schemeClr val="lt1"/>
+          </a:fontRef>
+        </p:style>
+        <p:txBody>
+          <a:bodyPr rtlCol="0" anchor="ctr"/>
+          <a:lstStyle/>
+          <a:p>
+            <a:pPr algn="ctr"/>
+          </a:p>
+        </p:txBody>
+      </p:sp>
+      <p:sp>
+        <p:nvSpPr>
+          <p:cNvPr id="4" name="Rectangle 3"/>
+          <p:cNvSpPr/>
+          <p:nvPr/>
+        </p:nvSpPr>
+        <p:spPr>
+          <a:xfrm>
+            <a:off x="0" y="1005840"/>
+            <a:ext cx="12188952" cy="54864"/>
+          </a:xfrm>
+          <a:prstGeom prst="rect">
+            <a:avLst/>
+          </a:prstGeom>
+          <a:solidFill>
+            <a:srgbClr val="E67E22"/>
+          </a:solidFill>
+          <a:ln>
+            <a:noFill/>
+          </a:ln>
+        </p:spPr>
+        <p:style>
+          <a:lnRef idx="1">
+            <a:schemeClr val="accent1"/>
+          </a:lnRef>
+          <a:fillRef idx="3">
+            <a:schemeClr val="accent1"/>
+          </a:fillRef>
+          <a:effectRef idx="2">
+            <a:schemeClr val="accent1"/>
+          </a:effectRef>
+          <a:fontRef idx="minor">
+            <a:schemeClr val="lt1"/>
+          </a:fontRef>
+        </p:style>
+        <p:txBody>
+          <a:bodyPr rtlCol="0" anchor="ctr"/>
+          <a:lstStyle/>
+          <a:p>
+            <a:pPr algn="ctr"/>
+          </a:p>
+        </p:txBody>
+      </p:sp>
+      <p:sp>
+        <p:nvSpPr>
+          <p:cNvPr id="5" name="TextBox 4"/>
+          <p:cNvSpPr txBox="1"/>
+          <p:nvPr/>
+        </p:nvSpPr>
+        <p:spPr>
+          <a:xfrm>
+            <a:off x="365760" y="228600"/>
+            <a:ext cx="10972800" cy="548640"/>
+          </a:xfrm>
+          <a:prstGeom prst="rect">
+            <a:avLst/>
+          </a:prstGeom>
+          <a:noFill/>
+        </p:spPr>
+        <p:txBody>
+          <a:bodyPr wrap="square">
+            <a:spAutoFit/>
+          </a:bodyPr>
+          <a:lstStyle/>
+          <a:p>
+            <a:pPr algn="l"/>
+            <a:r>
+              <a:rPr sz="2200" b="1">
+                <a:solidFill>
+                  <a:srgbClr val="FFFFFF"/>
+                </a:solidFill>
+              </a:rPr>
+              <a:t>08  |  DEEP DIVE:  MANAGER WATCH-LIST — 3-YEAR ENGAGEMENT TREND</a:t>
+            </a:r>
+          </a:p>
+        </p:txBody>
+      </p:sp>
+      <p:pic>
+        <p:nvPicPr>
+          <p:cNvPr id="6" name="Picture 5" descr="image.png"/>
+          <p:cNvPicPr>
+            <a:picLocks noChangeAspect="1"/>
+          </p:cNvPicPr>
+          <p:nvPr/>
+        </p:nvPicPr>
+        <p:blipFill>
+          <a:blip r:embed="rId2"/>
+          <a:stretch>
+            <a:fillRect/>
+          </a:stretch>
+        </p:blipFill>
+        <p:spPr>
+          <a:xfrm>
+            <a:off x="320040" y="1234440"/>
+            <a:ext cx="8046720" cy="4389120"/>
+          </a:xfrm>
+          <a:prstGeom prst="rect">
+            <a:avLst/>
+          </a:prstGeom>
+        </p:spPr>
+      </p:pic>
+      <p:sp>
+        <p:nvSpPr>
+          <p:cNvPr id="7" name="Rectangle 6"/>
+          <p:cNvSpPr/>
+          <p:nvPr/>
+        </p:nvSpPr>
+        <p:spPr>
+          <a:xfrm>
+            <a:off x="8595360" y="1371600"/>
+            <a:ext cx="5852160" cy="384048"/>
+          </a:xfrm>
+          <a:prstGeom prst="rect">
+            <a:avLst/>
+          </a:prstGeom>
+          <a:solidFill>
+            <a:srgbClr val="1B2A4A"/>
+          </a:solidFill>
+          <a:ln>
+            <a:noFill/>
+          </a:ln>
+        </p:spPr>
+        <p:style>
+          <a:lnRef idx="1">
+            <a:schemeClr val="accent1"/>
+          </a:lnRef>
+          <a:fillRef idx="3">
+            <a:schemeClr val="accent1"/>
+          </a:fillRef>
+          <a:effectRef idx="2">
+            <a:schemeClr val="accent1"/>
+          </a:effectRef>
+          <a:fontRef idx="minor">
+            <a:schemeClr val="lt1"/>
+          </a:fontRef>
+        </p:style>
+        <p:txBody>
+          <a:bodyPr rtlCol="0" anchor="ctr"/>
+          <a:lstStyle/>
+          <a:p>
+            <a:pPr algn="ctr"/>
+          </a:p>
+        </p:txBody>
+      </p:sp>
+      <p:sp>
+        <p:nvSpPr>
+          <p:cNvPr id="8" name="TextBox 7"/>
+          <p:cNvSpPr txBox="1"/>
+          <p:nvPr/>
+        </p:nvSpPr>
+        <p:spPr>
+          <a:xfrm>
+            <a:off x="8631936" y="1426464"/>
+            <a:ext cx="914400" cy="384048"/>
+          </a:xfrm>
+          <a:prstGeom prst="rect">
+            <a:avLst/>
+          </a:prstGeom>
+          <a:noFill/>
+        </p:spPr>
+        <p:txBody>
+          <a:bodyPr wrap="square">
+            <a:spAutoFit/>
+          </a:bodyPr>
+          <a:lstStyle/>
+          <a:p>
+            <a:pPr algn="l"/>
+            <a:r>
+              <a:rPr sz="800" b="1">
+                <a:solidFill>
+                  <a:srgbClr val="FFFFFF"/>
+                </a:solidFill>
+              </a:rPr>
+              <a:t>Manager</a:t>
+            </a:r>
+          </a:p>
+        </p:txBody>
+      </p:sp>
+      <p:sp>
+        <p:nvSpPr>
+          <p:cNvPr id="9" name="TextBox 8"/>
+          <p:cNvSpPr txBox="1"/>
+          <p:nvPr/>
+        </p:nvSpPr>
+        <p:spPr>
+          <a:xfrm>
+            <a:off x="9546336" y="1426464"/>
+            <a:ext cx="1005840" cy="384048"/>
+          </a:xfrm>
+          <a:prstGeom prst="rect">
+            <a:avLst/>
+          </a:prstGeom>
+          <a:noFill/>
+        </p:spPr>
+        <p:txBody>
+          <a:bodyPr wrap="square">
+            <a:spAutoFit/>
+          </a:bodyPr>
+          <a:lstStyle/>
+          <a:p>
+            <a:pPr algn="l"/>
+            <a:r>
+              <a:rPr sz="800" b="1">
+                <a:solidFill>
+                  <a:srgbClr val="FFFFFF"/>
+                </a:solidFill>
+              </a:rPr>
+              <a:t>Fn / Loc</a:t>
+            </a:r>
+          </a:p>
+        </p:txBody>
+      </p:sp>
+      <p:sp>
+        <p:nvSpPr>
+          <p:cNvPr id="10" name="TextBox 9"/>
+          <p:cNvSpPr txBox="1"/>
+          <p:nvPr/>
+        </p:nvSpPr>
+        <p:spPr>
+          <a:xfrm>
+            <a:off x="10552176" y="1426464"/>
+            <a:ext cx="548640" cy="384048"/>
+          </a:xfrm>
+          <a:prstGeom prst="rect">
+            <a:avLst/>
+          </a:prstGeom>
+          <a:noFill/>
+        </p:spPr>
+        <p:txBody>
+          <a:bodyPr wrap="square">
+            <a:spAutoFit/>
+          </a:bodyPr>
+          <a:lstStyle/>
+          <a:p>
+            <a:pPr algn="l"/>
+            <a:r>
+              <a:rPr sz="800" b="1">
+                <a:solidFill>
+                  <a:srgbClr val="FFFFFF"/>
+                </a:solidFill>
+              </a:rPr>
+              <a:t>Team</a:t>
+            </a:r>
+          </a:p>
+        </p:txBody>
+      </p:sp>
+      <p:sp>
+        <p:nvSpPr>
+          <p:cNvPr id="11" name="TextBox 10"/>
+          <p:cNvSpPr txBox="1"/>
+          <p:nvPr/>
+        </p:nvSpPr>
+        <p:spPr>
+          <a:xfrm>
+            <a:off x="11100816" y="1426464"/>
+            <a:ext cx="594360" cy="384048"/>
+          </a:xfrm>
+          <a:prstGeom prst="rect">
+            <a:avLst/>
+          </a:prstGeom>
+          <a:noFill/>
+        </p:spPr>
+        <p:txBody>
+          <a:bodyPr wrap="square">
+            <a:spAutoFit/>
+          </a:bodyPr>
+          <a:lstStyle/>
+          <a:p>
+            <a:pPr algn="l"/>
+            <a:r>
+              <a:rPr sz="800" b="1">
+                <a:solidFill>
+                  <a:srgbClr val="FFFFFF"/>
+                </a:solidFill>
+              </a:rPr>
+              <a:t>Attr%</a:t>
+            </a:r>
+          </a:p>
+        </p:txBody>
+      </p:sp>
+      <p:sp>
+        <p:nvSpPr>
+          <p:cNvPr id="12" name="TextBox 11"/>
+          <p:cNvSpPr txBox="1"/>
+          <p:nvPr/>
+        </p:nvSpPr>
+        <p:spPr>
+          <a:xfrm>
+            <a:off x="11695176" y="1426464"/>
+            <a:ext cx="594360" cy="384048"/>
+          </a:xfrm>
+          <a:prstGeom prst="rect">
+            <a:avLst/>
+          </a:prstGeom>
+          <a:noFill/>
+        </p:spPr>
+        <p:txBody>
+          <a:bodyPr wrap="square">
+            <a:spAutoFit/>
+          </a:bodyPr>
+          <a:lstStyle/>
+          <a:p>
+            <a:pPr algn="l"/>
+            <a:r>
+              <a:rPr sz="800" b="1">
+                <a:solidFill>
+                  <a:srgbClr val="FFFFFF"/>
+                </a:solidFill>
+              </a:rPr>
+              <a:t>Eng</a:t>
+            </a:r>
+          </a:p>
+        </p:txBody>
+      </p:sp>
+      <p:sp>
+        <p:nvSpPr>
+          <p:cNvPr id="13" name="TextBox 12"/>
+          <p:cNvSpPr txBox="1"/>
+          <p:nvPr/>
+        </p:nvSpPr>
+        <p:spPr>
+          <a:xfrm>
+            <a:off x="12289536" y="1426464"/>
+            <a:ext cx="1417320" cy="384048"/>
+          </a:xfrm>
+          <a:prstGeom prst="rect">
+            <a:avLst/>
+          </a:prstGeom>
+          <a:noFill/>
+        </p:spPr>
+        <p:txBody>
+          <a:bodyPr wrap="square">
+            <a:spAutoFit/>
+          </a:bodyPr>
+          <a:lstStyle/>
+          <a:p>
+            <a:pPr algn="l"/>
+            <a:r>
+              <a:rPr sz="800" b="1">
+                <a:solidFill>
+                  <a:srgbClr val="FFFFFF"/>
+                </a:solidFill>
+              </a:rPr>
+              <a:t>Signal</a:t>
+            </a:r>
+          </a:p>
+        </p:txBody>
+      </p:sp>
+      <p:sp>
+        <p:nvSpPr>
+          <p:cNvPr id="14" name="TextBox 13"/>
+          <p:cNvSpPr txBox="1"/>
+          <p:nvPr/>
+        </p:nvSpPr>
+        <p:spPr>
+          <a:xfrm>
+            <a:off x="13706856" y="1426464"/>
+            <a:ext cx="777240" cy="384048"/>
+          </a:xfrm>
+          <a:prstGeom prst="rect">
+            <a:avLst/>
+          </a:prstGeom>
+          <a:noFill/>
+        </p:spPr>
+        <p:txBody>
+          <a:bodyPr wrap="square">
+            <a:spAutoFit/>
+          </a:bodyPr>
+          <a:lstStyle/>
+          <a:p>
+            <a:pPr algn="l"/>
+            <a:r>
+              <a:rPr sz="800" b="1">
+                <a:solidFill>
+                  <a:srgbClr val="FFFFFF"/>
+                </a:solidFill>
+              </a:rPr>
+              <a:t>Status</a:t>
+            </a:r>
+          </a:p>
+        </p:txBody>
+      </p:sp>
+      <p:sp>
+        <p:nvSpPr>
+          <p:cNvPr id="15" name="Rectangle 14"/>
+          <p:cNvSpPr/>
+          <p:nvPr/>
+        </p:nvSpPr>
+        <p:spPr>
+          <a:xfrm>
+            <a:off x="8595360" y="1755648"/>
+            <a:ext cx="5852160" cy="384048"/>
+          </a:xfrm>
+          <a:prstGeom prst="rect">
+            <a:avLst/>
+          </a:prstGeom>
+          <a:solidFill>
+            <a:srgbClr val="FFF0F0"/>
+          </a:solidFill>
+          <a:ln>
+            <a:noFill/>
+          </a:ln>
+        </p:spPr>
+        <p:style>
+          <a:lnRef idx="1">
+            <a:schemeClr val="accent1"/>
+          </a:lnRef>
+          <a:fillRef idx="3">
+            <a:schemeClr val="accent1"/>
+          </a:fillRef>
+          <a:effectRef idx="2">
+            <a:schemeClr val="accent1"/>
+          </a:effectRef>
+          <a:fontRef idx="minor">
+            <a:schemeClr val="lt1"/>
+          </a:fontRef>
+        </p:style>
+        <p:txBody>
+          <a:bodyPr rtlCol="0" anchor="ctr"/>
+          <a:lstStyle/>
+          <a:p>
+            <a:pPr algn="ctr"/>
+          </a:p>
+        </p:txBody>
+      </p:sp>
+      <p:sp>
+        <p:nvSpPr>
+          <p:cNvPr id="16" name="TextBox 15"/>
+          <p:cNvSpPr txBox="1"/>
+          <p:nvPr/>
+        </p:nvSpPr>
+        <p:spPr>
+          <a:xfrm>
+            <a:off x="8631936" y="1810512"/>
+            <a:ext cx="914400" cy="384048"/>
+          </a:xfrm>
+          <a:prstGeom prst="rect">
+            <a:avLst/>
+          </a:prstGeom>
+          <a:noFill/>
+        </p:spPr>
+        <p:txBody>
+          <a:bodyPr wrap="square">
+            <a:spAutoFit/>
+          </a:bodyPr>
+          <a:lstStyle/>
+          <a:p>
+            <a:pPr algn="l"/>
+            <a:r>
+              <a:rPr sz="800" b="0">
+                <a:solidFill>
+                  <a:srgbClr val="2C3E50"/>
+                </a:solidFill>
+              </a:rPr>
+              <a:t>060f8cec</a:t>
+            </a:r>
+          </a:p>
+        </p:txBody>
+      </p:sp>
+      <p:sp>
+        <p:nvSpPr>
+          <p:cNvPr id="17" name="TextBox 16"/>
+          <p:cNvSpPr txBox="1"/>
+          <p:nvPr/>
+        </p:nvSpPr>
+        <p:spPr>
+          <a:xfrm>
+            <a:off x="9546336" y="1810512"/>
+            <a:ext cx="1005840" cy="384048"/>
+          </a:xfrm>
+          <a:prstGeom prst="rect">
+            <a:avLst/>
+          </a:prstGeom>
+          <a:noFill/>
+        </p:spPr>
+        <p:txBody>
+          <a:bodyPr wrap="square">
+            <a:spAutoFit/>
+          </a:bodyPr>
+          <a:lstStyle/>
+          <a:p>
+            <a:pPr algn="l"/>
+            <a:r>
+              <a:rPr sz="800" b="0">
+                <a:solidFill>
+                  <a:srgbClr val="2C3E50"/>
+                </a:solidFill>
+              </a:rPr>
+              <a:t>Eng / SF</a:t>
+            </a:r>
+          </a:p>
+        </p:txBody>
+      </p:sp>
+      <p:sp>
+        <p:nvSpPr>
+          <p:cNvPr id="18" name="TextBox 17"/>
+          <p:cNvSpPr txBox="1"/>
+          <p:nvPr/>
+        </p:nvSpPr>
+        <p:spPr>
+          <a:xfrm>
+            <a:off x="10552176" y="1810512"/>
+            <a:ext cx="548640" cy="384048"/>
+          </a:xfrm>
+          <a:prstGeom prst="rect">
+            <a:avLst/>
+          </a:prstGeom>
+          <a:noFill/>
+        </p:spPr>
+        <p:txBody>
+          <a:bodyPr wrap="square">
+            <a:spAutoFit/>
+          </a:bodyPr>
+          <a:lstStyle/>
+          <a:p>
+            <a:pPr algn="l"/>
+            <a:r>
+              <a:rPr sz="800" b="0">
+                <a:solidFill>
+                  <a:srgbClr val="2C3E50"/>
+                </a:solidFill>
+              </a:rPr>
+              <a:t>25</a:t>
+            </a:r>
+          </a:p>
+        </p:txBody>
+      </p:sp>
+      <p:sp>
+        <p:nvSpPr>
+          <p:cNvPr id="19" name="TextBox 18"/>
+          <p:cNvSpPr txBox="1"/>
+          <p:nvPr/>
+        </p:nvSpPr>
+        <p:spPr>
+          <a:xfrm>
+            <a:off x="11100816" y="1810512"/>
+            <a:ext cx="594360" cy="384048"/>
+          </a:xfrm>
+          <a:prstGeom prst="rect">
+            <a:avLst/>
+          </a:prstGeom>
+          <a:noFill/>
+        </p:spPr>
+        <p:txBody>
+          <a:bodyPr wrap="square">
+            <a:spAutoFit/>
+          </a:bodyPr>
+          <a:lstStyle/>
+          <a:p>
+            <a:pPr algn="l"/>
+            <a:r>
+              <a:rPr sz="800" b="0">
+                <a:solidFill>
+                  <a:srgbClr val="2C3E50"/>
+                </a:solidFill>
+              </a:rPr>
+              <a:t>56%</a:t>
+            </a:r>
+          </a:p>
+        </p:txBody>
+      </p:sp>
+      <p:sp>
+        <p:nvSpPr>
+          <p:cNvPr id="20" name="TextBox 19"/>
+          <p:cNvSpPr txBox="1"/>
+          <p:nvPr/>
+        </p:nvSpPr>
+        <p:spPr>
+          <a:xfrm>
+            <a:off x="11695176" y="1810512"/>
+            <a:ext cx="594360" cy="384048"/>
+          </a:xfrm>
+          <a:prstGeom prst="rect">
+            <a:avLst/>
+          </a:prstGeom>
+          <a:noFill/>
+        </p:spPr>
+        <p:txBody>
+          <a:bodyPr wrap="square">
+            <a:spAutoFit/>
+          </a:bodyPr>
+          <a:lstStyle/>
+          <a:p>
+            <a:pPr algn="l"/>
+            <a:r>
+              <a:rPr sz="800" b="0">
+                <a:solidFill>
+                  <a:srgbClr val="2C3E50"/>
+                </a:solidFill>
+              </a:rPr>
+              <a:t>5.3 ↓</a:t>
+            </a:r>
+          </a:p>
+        </p:txBody>
+      </p:sp>
+      <p:sp>
+        <p:nvSpPr>
+          <p:cNvPr id="21" name="TextBox 20"/>
+          <p:cNvSpPr txBox="1"/>
+          <p:nvPr/>
+        </p:nvSpPr>
+        <p:spPr>
+          <a:xfrm>
+            <a:off x="12289536" y="1810512"/>
+            <a:ext cx="1417320" cy="384048"/>
+          </a:xfrm>
+          <a:prstGeom prst="rect">
+            <a:avLst/>
+          </a:prstGeom>
+          <a:noFill/>
+        </p:spPr>
+        <p:txBody>
+          <a:bodyPr wrap="square">
+            <a:spAutoFit/>
+          </a:bodyPr>
+          <a:lstStyle/>
+          <a:p>
+            <a:pPr algn="l"/>
+            <a:r>
+              <a:rPr sz="800" b="0">
+                <a:solidFill>
+                  <a:srgbClr val="2C3E50"/>
+                </a:solidFill>
+              </a:rPr>
+              <a:t>3 yrs declining</a:t>
+            </a:r>
+          </a:p>
+        </p:txBody>
+      </p:sp>
+      <p:sp>
+        <p:nvSpPr>
+          <p:cNvPr id="22" name="TextBox 21"/>
+          <p:cNvSpPr txBox="1"/>
+          <p:nvPr/>
+        </p:nvSpPr>
+        <p:spPr>
+          <a:xfrm>
+            <a:off x="13706856" y="1810512"/>
+            <a:ext cx="777240" cy="384048"/>
+          </a:xfrm>
+          <a:prstGeom prst="rect">
+            <a:avLst/>
+          </a:prstGeom>
+          <a:noFill/>
+        </p:spPr>
+        <p:txBody>
+          <a:bodyPr wrap="square">
+            <a:spAutoFit/>
+          </a:bodyPr>
+          <a:lstStyle/>
+          <a:p>
+            <a:pPr algn="l"/>
+            <a:r>
+              <a:rPr sz="800" b="1">
+                <a:solidFill>
+                  <a:srgbClr val="C0392B"/>
+                </a:solidFill>
+              </a:rPr>
+              <a:t>PRIORITY</a:t>
+            </a:r>
+          </a:p>
+        </p:txBody>
+      </p:sp>
+      <p:sp>
+        <p:nvSpPr>
+          <p:cNvPr id="23" name="Rectangle 22"/>
+          <p:cNvSpPr/>
+          <p:nvPr/>
+        </p:nvSpPr>
+        <p:spPr>
+          <a:xfrm>
+            <a:off x="8595360" y="2139696"/>
+            <a:ext cx="5852160" cy="384048"/>
+          </a:xfrm>
+          <a:prstGeom prst="rect">
+            <a:avLst/>
+          </a:prstGeom>
+          <a:solidFill>
+            <a:srgbClr val="FFF0F0"/>
+          </a:solidFill>
+          <a:ln>
+            <a:noFill/>
+          </a:ln>
+        </p:spPr>
+        <p:style>
+          <a:lnRef idx="1">
+            <a:schemeClr val="accent1"/>
+          </a:lnRef>
+          <a:fillRef idx="3">
+            <a:schemeClr val="accent1"/>
+          </a:fillRef>
+          <a:effectRef idx="2">
+            <a:schemeClr val="accent1"/>
+          </a:effectRef>
+          <a:fontRef idx="minor">
+            <a:schemeClr val="lt1"/>
+          </a:fontRef>
+        </p:style>
+        <p:txBody>
+          <a:bodyPr rtlCol="0" anchor="ctr"/>
+          <a:lstStyle/>
+          <a:p>
+            <a:pPr algn="ctr"/>
+          </a:p>
+        </p:txBody>
+      </p:sp>
+      <p:sp>
+        <p:nvSpPr>
+          <p:cNvPr id="24" name="TextBox 23"/>
+          <p:cNvSpPr txBox="1"/>
+          <p:nvPr/>
+        </p:nvSpPr>
+        <p:spPr>
+          <a:xfrm>
+            <a:off x="8631936" y="2194560"/>
+            <a:ext cx="914400" cy="384048"/>
+          </a:xfrm>
+          <a:prstGeom prst="rect">
+            <a:avLst/>
+          </a:prstGeom>
+          <a:noFill/>
+        </p:spPr>
+        <p:txBody>
+          <a:bodyPr wrap="square">
+            <a:spAutoFit/>
+          </a:bodyPr>
+          <a:lstStyle/>
+          <a:p>
+            <a:pPr algn="l"/>
+            <a:r>
+              <a:rPr sz="800" b="0">
+                <a:solidFill>
+                  <a:srgbClr val="2C3E50"/>
+                </a:solidFill>
+              </a:rPr>
+              <a:t>20c21d2b</a:t>
+            </a:r>
+          </a:p>
+        </p:txBody>
+      </p:sp>
+      <p:sp>
+        <p:nvSpPr>
+          <p:cNvPr id="25" name="TextBox 24"/>
+          <p:cNvSpPr txBox="1"/>
+          <p:nvPr/>
+        </p:nvSpPr>
+        <p:spPr>
+          <a:xfrm>
+            <a:off x="9546336" y="2194560"/>
+            <a:ext cx="1005840" cy="384048"/>
+          </a:xfrm>
+          <a:prstGeom prst="rect">
+            <a:avLst/>
+          </a:prstGeom>
+          <a:noFill/>
+        </p:spPr>
+        <p:txBody>
+          <a:bodyPr wrap="square">
+            <a:spAutoFit/>
+          </a:bodyPr>
+          <a:lstStyle/>
+          <a:p>
+            <a:pPr algn="l"/>
+            <a:r>
+              <a:rPr sz="800" b="0">
+                <a:solidFill>
+                  <a:srgbClr val="2C3E50"/>
+                </a:solidFill>
+              </a:rPr>
+              <a:t>Eng / SF</a:t>
+            </a:r>
+          </a:p>
+        </p:txBody>
+      </p:sp>
+      <p:sp>
+        <p:nvSpPr>
+          <p:cNvPr id="26" name="TextBox 25"/>
+          <p:cNvSpPr txBox="1"/>
+          <p:nvPr/>
+        </p:nvSpPr>
+        <p:spPr>
+          <a:xfrm>
+            <a:off x="10552176" y="2194560"/>
+            <a:ext cx="548640" cy="384048"/>
+          </a:xfrm>
+          <a:prstGeom prst="rect">
+            <a:avLst/>
+          </a:prstGeom>
+          <a:noFill/>
+        </p:spPr>
+        <p:txBody>
+          <a:bodyPr wrap="square">
+            <a:spAutoFit/>
+          </a:bodyPr>
+          <a:lstStyle/>
+          <a:p>
+            <a:pPr algn="l"/>
+            <a:r>
+              <a:rPr sz="800" b="0">
+                <a:solidFill>
+                  <a:srgbClr val="2C3E50"/>
+                </a:solidFill>
+              </a:rPr>
+              <a:t>22</a:t>
+            </a:r>
+          </a:p>
+        </p:txBody>
+      </p:sp>
+      <p:sp>
+        <p:nvSpPr>
+          <p:cNvPr id="27" name="TextBox 26"/>
+          <p:cNvSpPr txBox="1"/>
+          <p:nvPr/>
+        </p:nvSpPr>
+        <p:spPr>
+          <a:xfrm>
+            <a:off x="11100816" y="2194560"/>
+            <a:ext cx="594360" cy="384048"/>
+          </a:xfrm>
+          <a:prstGeom prst="rect">
+            <a:avLst/>
+          </a:prstGeom>
+          <a:noFill/>
+        </p:spPr>
+        <p:txBody>
+          <a:bodyPr wrap="square">
+            <a:spAutoFit/>
+          </a:bodyPr>
+          <a:lstStyle/>
+          <a:p>
+            <a:pPr algn="l"/>
+            <a:r>
+              <a:rPr sz="800" b="0">
+                <a:solidFill>
+                  <a:srgbClr val="2C3E50"/>
+                </a:solidFill>
+              </a:rPr>
+              <a:t>55%</a:t>
+            </a:r>
+          </a:p>
+        </p:txBody>
+      </p:sp>
+      <p:sp>
+        <p:nvSpPr>
+          <p:cNvPr id="28" name="TextBox 27"/>
+          <p:cNvSpPr txBox="1"/>
+          <p:nvPr/>
+        </p:nvSpPr>
+        <p:spPr>
+          <a:xfrm>
+            <a:off x="11695176" y="2194560"/>
+            <a:ext cx="594360" cy="384048"/>
+          </a:xfrm>
+          <a:prstGeom prst="rect">
+            <a:avLst/>
+          </a:prstGeom>
+          <a:noFill/>
+        </p:spPr>
+        <p:txBody>
+          <a:bodyPr wrap="square">
+            <a:spAutoFit/>
+          </a:bodyPr>
+          <a:lstStyle/>
+          <a:p>
+            <a:pPr algn="l"/>
+            <a:r>
+              <a:rPr sz="800" b="0">
+                <a:solidFill>
+                  <a:srgbClr val="2C3E50"/>
+                </a:solidFill>
+              </a:rPr>
+              <a:t>5.4 ↓</a:t>
+            </a:r>
+          </a:p>
+        </p:txBody>
+      </p:sp>
+      <p:sp>
+        <p:nvSpPr>
+          <p:cNvPr id="29" name="TextBox 28"/>
+          <p:cNvSpPr txBox="1"/>
+          <p:nvPr/>
+        </p:nvSpPr>
+        <p:spPr>
+          <a:xfrm>
+            <a:off x="12289536" y="2194560"/>
+            <a:ext cx="1417320" cy="384048"/>
+          </a:xfrm>
+          <a:prstGeom prst="rect">
+            <a:avLst/>
+          </a:prstGeom>
+          <a:noFill/>
+        </p:spPr>
+        <p:txBody>
+          <a:bodyPr wrap="square">
+            <a:spAutoFit/>
+          </a:bodyPr>
+          <a:lstStyle/>
+          <a:p>
+            <a:pPr algn="l"/>
+            <a:r>
+              <a:rPr sz="800" b="0">
+                <a:solidFill>
+                  <a:srgbClr val="2C3E50"/>
+                </a:solidFill>
+              </a:rPr>
+              <a:t>Recovery reversed</a:t>
+            </a:r>
+          </a:p>
+        </p:txBody>
+      </p:sp>
+      <p:sp>
+        <p:nvSpPr>
+          <p:cNvPr id="30" name="TextBox 29"/>
+          <p:cNvSpPr txBox="1"/>
+          <p:nvPr/>
+        </p:nvSpPr>
+        <p:spPr>
+          <a:xfrm>
+            <a:off x="13706856" y="2194560"/>
+            <a:ext cx="777240" cy="384048"/>
+          </a:xfrm>
+          <a:prstGeom prst="rect">
+            <a:avLst/>
+          </a:prstGeom>
+          <a:noFill/>
+        </p:spPr>
+        <p:txBody>
+          <a:bodyPr wrap="square">
+            <a:spAutoFit/>
+          </a:bodyPr>
+          <a:lstStyle/>
+          <a:p>
+            <a:pPr algn="l"/>
+            <a:r>
+              <a:rPr sz="800" b="1">
+                <a:solidFill>
+                  <a:srgbClr val="C0392B"/>
+                </a:solidFill>
+              </a:rPr>
+              <a:t>PRIORITY</a:t>
+            </a:r>
+          </a:p>
+        </p:txBody>
+      </p:sp>
+      <p:sp>
+        <p:nvSpPr>
+          <p:cNvPr id="31" name="Rectangle 30"/>
+          <p:cNvSpPr/>
+          <p:nvPr/>
+        </p:nvSpPr>
+        <p:spPr>
+          <a:xfrm>
+            <a:off x="8595360" y="2523744"/>
+            <a:ext cx="5852160" cy="384048"/>
+          </a:xfrm>
+          <a:prstGeom prst="rect">
+            <a:avLst/>
+          </a:prstGeom>
+          <a:solidFill>
+            <a:srgbClr val="FFF9F0"/>
+          </a:solidFill>
+          <a:ln>
+            <a:noFill/>
+          </a:ln>
+        </p:spPr>
+        <p:style>
+          <a:lnRef idx="1">
+            <a:schemeClr val="accent1"/>
+          </a:lnRef>
+          <a:fillRef idx="3">
+            <a:schemeClr val="accent1"/>
+          </a:fillRef>
+          <a:effectRef idx="2">
+            <a:schemeClr val="accent1"/>
+          </a:effectRef>
+          <a:fontRef idx="minor">
+            <a:schemeClr val="lt1"/>
+          </a:fontRef>
+        </p:style>
+        <p:txBody>
+          <a:bodyPr rtlCol="0" anchor="ctr"/>
+          <a:lstStyle/>
+          <a:p>
+            <a:pPr algn="ctr"/>
+          </a:p>
+        </p:txBody>
+      </p:sp>
+      <p:sp>
+        <p:nvSpPr>
+          <p:cNvPr id="32" name="TextBox 31"/>
+          <p:cNvSpPr txBox="1"/>
+          <p:nvPr/>
+        </p:nvSpPr>
+        <p:spPr>
+          <a:xfrm>
+            <a:off x="8631936" y="2578608"/>
+            <a:ext cx="914400" cy="384048"/>
+          </a:xfrm>
+          <a:prstGeom prst="rect">
+            <a:avLst/>
+          </a:prstGeom>
+          <a:noFill/>
+        </p:spPr>
+        <p:txBody>
+          <a:bodyPr wrap="square">
+            <a:spAutoFit/>
+          </a:bodyPr>
+          <a:lstStyle/>
+          <a:p>
+            <a:pPr algn="l"/>
+            <a:r>
+              <a:rPr sz="800" b="0">
+                <a:solidFill>
+                  <a:srgbClr val="2C3E50"/>
+                </a:solidFill>
+              </a:rPr>
+              <a:t>fbad34d8</a:t>
+            </a:r>
+          </a:p>
+        </p:txBody>
+      </p:sp>
+      <p:sp>
+        <p:nvSpPr>
+          <p:cNvPr id="33" name="TextBox 32"/>
+          <p:cNvSpPr txBox="1"/>
+          <p:nvPr/>
+        </p:nvSpPr>
+        <p:spPr>
+          <a:xfrm>
+            <a:off x="9546336" y="2578608"/>
+            <a:ext cx="1005840" cy="384048"/>
+          </a:xfrm>
+          <a:prstGeom prst="rect">
+            <a:avLst/>
+          </a:prstGeom>
+          <a:noFill/>
+        </p:spPr>
+        <p:txBody>
+          <a:bodyPr wrap="square">
+            <a:spAutoFit/>
+          </a:bodyPr>
+          <a:lstStyle/>
+          <a:p>
+            <a:pPr algn="l"/>
+            <a:r>
+              <a:rPr sz="800" b="0">
+                <a:solidFill>
+                  <a:srgbClr val="2C3E50"/>
+                </a:solidFill>
+              </a:rPr>
+              <a:t>Ops / Remote</a:t>
+            </a:r>
+          </a:p>
+        </p:txBody>
+      </p:sp>
+      <p:sp>
+        <p:nvSpPr>
+          <p:cNvPr id="34" name="TextBox 33"/>
+          <p:cNvSpPr txBox="1"/>
+          <p:nvPr/>
+        </p:nvSpPr>
+        <p:spPr>
+          <a:xfrm>
+            <a:off x="10552176" y="2578608"/>
+            <a:ext cx="548640" cy="384048"/>
+          </a:xfrm>
+          <a:prstGeom prst="rect">
+            <a:avLst/>
+          </a:prstGeom>
+          <a:noFill/>
+        </p:spPr>
+        <p:txBody>
+          <a:bodyPr wrap="square">
+            <a:spAutoFit/>
+          </a:bodyPr>
+          <a:lstStyle/>
+          <a:p>
+            <a:pPr algn="l"/>
+            <a:r>
+              <a:rPr sz="800" b="0">
+                <a:solidFill>
+                  <a:srgbClr val="2C3E50"/>
+                </a:solidFill>
+              </a:rPr>
+              <a:t> 8</a:t>
+            </a:r>
+          </a:p>
+        </p:txBody>
+      </p:sp>
+      <p:sp>
+        <p:nvSpPr>
+          <p:cNvPr id="35" name="TextBox 34"/>
+          <p:cNvSpPr txBox="1"/>
+          <p:nvPr/>
+        </p:nvSpPr>
+        <p:spPr>
+          <a:xfrm>
+            <a:off x="11100816" y="2578608"/>
+            <a:ext cx="594360" cy="384048"/>
+          </a:xfrm>
+          <a:prstGeom prst="rect">
+            <a:avLst/>
+          </a:prstGeom>
+          <a:noFill/>
+        </p:spPr>
+        <p:txBody>
+          <a:bodyPr wrap="square">
+            <a:spAutoFit/>
+          </a:bodyPr>
+          <a:lstStyle/>
+          <a:p>
+            <a:pPr algn="l"/>
+            <a:r>
+              <a:rPr sz="800" b="0">
+                <a:solidFill>
+                  <a:srgbClr val="2C3E50"/>
+                </a:solidFill>
+              </a:rPr>
+              <a:t>50%</a:t>
+            </a:r>
+          </a:p>
+        </p:txBody>
+      </p:sp>
+      <p:sp>
+        <p:nvSpPr>
+          <p:cNvPr id="36" name="TextBox 35"/>
+          <p:cNvSpPr txBox="1"/>
+          <p:nvPr/>
+        </p:nvSpPr>
+        <p:spPr>
+          <a:xfrm>
+            <a:off x="11695176" y="2578608"/>
+            <a:ext cx="594360" cy="384048"/>
+          </a:xfrm>
+          <a:prstGeom prst="rect">
+            <a:avLst/>
+          </a:prstGeom>
+          <a:noFill/>
+        </p:spPr>
+        <p:txBody>
+          <a:bodyPr wrap="square">
+            <a:spAutoFit/>
+          </a:bodyPr>
+          <a:lstStyle/>
+          <a:p>
+            <a:pPr algn="l"/>
+            <a:r>
+              <a:rPr sz="800" b="0">
+                <a:solidFill>
+                  <a:srgbClr val="2C3E50"/>
+                </a:solidFill>
+              </a:rPr>
+              <a:t>6.9</a:t>
+            </a:r>
+          </a:p>
+        </p:txBody>
+      </p:sp>
+      <p:sp>
+        <p:nvSpPr>
+          <p:cNvPr id="37" name="TextBox 36"/>
+          <p:cNvSpPr txBox="1"/>
+          <p:nvPr/>
+        </p:nvSpPr>
+        <p:spPr>
+          <a:xfrm>
+            <a:off x="12289536" y="2578608"/>
+            <a:ext cx="1417320" cy="384048"/>
+          </a:xfrm>
+          <a:prstGeom prst="rect">
+            <a:avLst/>
+          </a:prstGeom>
+          <a:noFill/>
+        </p:spPr>
+        <p:txBody>
+          <a:bodyPr wrap="square">
+            <a:spAutoFit/>
+          </a:bodyPr>
+          <a:lstStyle/>
+          <a:p>
+            <a:pPr algn="l"/>
+            <a:r>
+              <a:rPr sz="800" b="0">
+                <a:solidFill>
+                  <a:srgbClr val="2C3E50"/>
+                </a:solidFill>
+              </a:rPr>
+              <a:t>Low eng, decent mgr</a:t>
+            </a:r>
+          </a:p>
+        </p:txBody>
+      </p:sp>
+      <p:sp>
+        <p:nvSpPr>
+          <p:cNvPr id="38" name="TextBox 37"/>
+          <p:cNvSpPr txBox="1"/>
+          <p:nvPr/>
+        </p:nvSpPr>
+        <p:spPr>
+          <a:xfrm>
+            <a:off x="13706856" y="2578608"/>
+            <a:ext cx="777240" cy="384048"/>
+          </a:xfrm>
+          <a:prstGeom prst="rect">
+            <a:avLst/>
+          </a:prstGeom>
+          <a:noFill/>
+        </p:spPr>
+        <p:txBody>
+          <a:bodyPr wrap="square">
+            <a:spAutoFit/>
+          </a:bodyPr>
+          <a:lstStyle/>
+          <a:p>
+            <a:pPr algn="l"/>
+            <a:r>
+              <a:rPr sz="800" b="1">
+                <a:solidFill>
+                  <a:srgbClr val="E67E22"/>
+                </a:solidFill>
+              </a:rPr>
+              <a:t>WATCH</a:t>
+            </a:r>
+          </a:p>
+        </p:txBody>
+      </p:sp>
+      <p:sp>
+        <p:nvSpPr>
+          <p:cNvPr id="39" name="Rectangle 38"/>
+          <p:cNvSpPr/>
+          <p:nvPr/>
+        </p:nvSpPr>
+        <p:spPr>
+          <a:xfrm>
+            <a:off x="8595360" y="2907792"/>
+            <a:ext cx="5852160" cy="384048"/>
+          </a:xfrm>
+          <a:prstGeom prst="rect">
+            <a:avLst/>
+          </a:prstGeom>
+          <a:solidFill>
+            <a:srgbClr val="FFF9F0"/>
+          </a:solidFill>
+          <a:ln>
+            <a:noFill/>
+          </a:ln>
+        </p:spPr>
+        <p:style>
+          <a:lnRef idx="1">
+            <a:schemeClr val="accent1"/>
+          </a:lnRef>
+          <a:fillRef idx="3">
+            <a:schemeClr val="accent1"/>
+          </a:fillRef>
+          <a:effectRef idx="2">
+            <a:schemeClr val="accent1"/>
+          </a:effectRef>
+          <a:fontRef idx="minor">
+            <a:schemeClr val="lt1"/>
+          </a:fontRef>
+        </p:style>
+        <p:txBody>
+          <a:bodyPr rtlCol="0" anchor="ctr"/>
+          <a:lstStyle/>
+          <a:p>
+            <a:pPr algn="ctr"/>
+          </a:p>
+        </p:txBody>
+      </p:sp>
+      <p:sp>
+        <p:nvSpPr>
+          <p:cNvPr id="40" name="TextBox 39"/>
+          <p:cNvSpPr txBox="1"/>
+          <p:nvPr/>
+        </p:nvSpPr>
+        <p:spPr>
+          <a:xfrm>
+            <a:off x="8631936" y="2962656"/>
+            <a:ext cx="914400" cy="384048"/>
+          </a:xfrm>
+          <a:prstGeom prst="rect">
+            <a:avLst/>
+          </a:prstGeom>
+          <a:noFill/>
+        </p:spPr>
+        <p:txBody>
+          <a:bodyPr wrap="square">
+            <a:spAutoFit/>
+          </a:bodyPr>
+          <a:lstStyle/>
+          <a:p>
+            <a:pPr algn="l"/>
+            <a:r>
+              <a:rPr sz="800" b="0">
+                <a:solidFill>
+                  <a:srgbClr val="2C3E50"/>
+                </a:solidFill>
+              </a:rPr>
+              <a:t>db3ccea8</a:t>
+            </a:r>
+          </a:p>
+        </p:txBody>
+      </p:sp>
+      <p:sp>
+        <p:nvSpPr>
+          <p:cNvPr id="41" name="TextBox 40"/>
+          <p:cNvSpPr txBox="1"/>
+          <p:nvPr/>
+        </p:nvSpPr>
+        <p:spPr>
+          <a:xfrm>
+            <a:off x="9546336" y="2962656"/>
+            <a:ext cx="1005840" cy="384048"/>
+          </a:xfrm>
+          <a:prstGeom prst="rect">
+            <a:avLst/>
+          </a:prstGeom>
+          <a:noFill/>
+        </p:spPr>
+        <p:txBody>
+          <a:bodyPr wrap="square">
+            <a:spAutoFit/>
+          </a:bodyPr>
+          <a:lstStyle/>
+          <a:p>
+            <a:pPr algn="l"/>
+            <a:r>
+              <a:rPr sz="800" b="0">
+                <a:solidFill>
+                  <a:srgbClr val="2C3E50"/>
+                </a:solidFill>
+              </a:rPr>
+              <a:t>Ops / Remote</a:t>
+            </a:r>
+          </a:p>
+        </p:txBody>
+      </p:sp>
+      <p:sp>
+        <p:nvSpPr>
+          <p:cNvPr id="42" name="TextBox 41"/>
+          <p:cNvSpPr txBox="1"/>
+          <p:nvPr/>
+        </p:nvSpPr>
+        <p:spPr>
+          <a:xfrm>
+            <a:off x="10552176" y="2962656"/>
+            <a:ext cx="548640" cy="384048"/>
+          </a:xfrm>
+          <a:prstGeom prst="rect">
+            <a:avLst/>
+          </a:prstGeom>
+          <a:noFill/>
+        </p:spPr>
+        <p:txBody>
+          <a:bodyPr wrap="square">
+            <a:spAutoFit/>
+          </a:bodyPr>
+          <a:lstStyle/>
+          <a:p>
+            <a:pPr algn="l"/>
+            <a:r>
+              <a:rPr sz="800" b="0">
+                <a:solidFill>
+                  <a:srgbClr val="2C3E50"/>
+                </a:solidFill>
+              </a:rPr>
+              <a:t> 8</a:t>
+            </a:r>
+          </a:p>
+        </p:txBody>
+      </p:sp>
+      <p:sp>
+        <p:nvSpPr>
+          <p:cNvPr id="43" name="TextBox 42"/>
+          <p:cNvSpPr txBox="1"/>
+          <p:nvPr/>
+        </p:nvSpPr>
+        <p:spPr>
+          <a:xfrm>
+            <a:off x="11100816" y="2962656"/>
+            <a:ext cx="594360" cy="384048"/>
+          </a:xfrm>
+          <a:prstGeom prst="rect">
+            <a:avLst/>
+          </a:prstGeom>
+          <a:noFill/>
+        </p:spPr>
+        <p:txBody>
+          <a:bodyPr wrap="square">
+            <a:spAutoFit/>
+          </a:bodyPr>
+          <a:lstStyle/>
+          <a:p>
+            <a:pPr algn="l"/>
+            <a:r>
+              <a:rPr sz="800" b="0">
+                <a:solidFill>
+                  <a:srgbClr val="2C3E50"/>
+                </a:solidFill>
+              </a:rPr>
+              <a:t>38%</a:t>
+            </a:r>
+          </a:p>
+        </p:txBody>
+      </p:sp>
+      <p:sp>
+        <p:nvSpPr>
+          <p:cNvPr id="44" name="TextBox 43"/>
+          <p:cNvSpPr txBox="1"/>
+          <p:nvPr/>
+        </p:nvSpPr>
+        <p:spPr>
+          <a:xfrm>
+            <a:off x="11695176" y="2962656"/>
+            <a:ext cx="594360" cy="384048"/>
+          </a:xfrm>
+          <a:prstGeom prst="rect">
+            <a:avLst/>
+          </a:prstGeom>
+          <a:noFill/>
+        </p:spPr>
+        <p:txBody>
+          <a:bodyPr wrap="square">
+            <a:spAutoFit/>
+          </a:bodyPr>
+          <a:lstStyle/>
+          <a:p>
+            <a:pPr algn="l"/>
+            <a:r>
+              <a:rPr sz="800" b="0">
+                <a:solidFill>
+                  <a:srgbClr val="2C3E50"/>
+                </a:solidFill>
+              </a:rPr>
+              <a:t>6.8</a:t>
+            </a:r>
+          </a:p>
+        </p:txBody>
+      </p:sp>
+      <p:sp>
+        <p:nvSpPr>
+          <p:cNvPr id="45" name="TextBox 44"/>
+          <p:cNvSpPr txBox="1"/>
+          <p:nvPr/>
+        </p:nvSpPr>
+        <p:spPr>
+          <a:xfrm>
+            <a:off x="12289536" y="2962656"/>
+            <a:ext cx="1417320" cy="384048"/>
+          </a:xfrm>
+          <a:prstGeom prst="rect">
+            <a:avLst/>
+          </a:prstGeom>
+          <a:noFill/>
+        </p:spPr>
+        <p:txBody>
+          <a:bodyPr wrap="square">
+            <a:spAutoFit/>
+          </a:bodyPr>
+          <a:lstStyle/>
+          <a:p>
+            <a:pPr algn="l"/>
+            <a:r>
+              <a:rPr sz="800" b="0">
+                <a:solidFill>
+                  <a:srgbClr val="2C3E50"/>
+                </a:solidFill>
+              </a:rPr>
+              <a:t>Early exits (3mo)</a:t>
+            </a:r>
+          </a:p>
+        </p:txBody>
+      </p:sp>
+      <p:sp>
+        <p:nvSpPr>
+          <p:cNvPr id="46" name="TextBox 45"/>
+          <p:cNvSpPr txBox="1"/>
+          <p:nvPr/>
+        </p:nvSpPr>
+        <p:spPr>
+          <a:xfrm>
+            <a:off x="13706856" y="2962656"/>
+            <a:ext cx="777240" cy="384048"/>
+          </a:xfrm>
+          <a:prstGeom prst="rect">
+            <a:avLst/>
+          </a:prstGeom>
+          <a:noFill/>
+        </p:spPr>
+        <p:txBody>
+          <a:bodyPr wrap="square">
+            <a:spAutoFit/>
+          </a:bodyPr>
+          <a:lstStyle/>
+          <a:p>
+            <a:pPr algn="l"/>
+            <a:r>
+              <a:rPr sz="800" b="1">
+                <a:solidFill>
+                  <a:srgbClr val="E67E22"/>
+                </a:solidFill>
+              </a:rPr>
+              <a:t>WATCH</a:t>
+            </a:r>
+          </a:p>
+        </p:txBody>
+      </p:sp>
+      <p:sp>
+        <p:nvSpPr>
+          <p:cNvPr id="47" name="Rectangle 46"/>
+          <p:cNvSpPr/>
+          <p:nvPr/>
+        </p:nvSpPr>
+        <p:spPr>
+          <a:xfrm>
+            <a:off x="8595360" y="3291840"/>
+            <a:ext cx="5852160" cy="384048"/>
+          </a:xfrm>
+          <a:prstGeom prst="rect">
+            <a:avLst/>
+          </a:prstGeom>
+          <a:solidFill>
+            <a:srgbClr val="FFF9F0"/>
+          </a:solidFill>
+          <a:ln>
+            <a:noFill/>
+          </a:ln>
+        </p:spPr>
+        <p:style>
+          <a:lnRef idx="1">
+            <a:schemeClr val="accent1"/>
+          </a:lnRef>
+          <a:fillRef idx="3">
+            <a:schemeClr val="accent1"/>
+          </a:fillRef>
+          <a:effectRef idx="2">
+            <a:schemeClr val="accent1"/>
+          </a:effectRef>
+          <a:fontRef idx="minor">
+            <a:schemeClr val="lt1"/>
+          </a:fontRef>
+        </p:style>
+        <p:txBody>
+          <a:bodyPr rtlCol="0" anchor="ctr"/>
+          <a:lstStyle/>
+          <a:p>
+            <a:pPr algn="ctr"/>
+          </a:p>
+        </p:txBody>
+      </p:sp>
+      <p:sp>
+        <p:nvSpPr>
+          <p:cNvPr id="48" name="TextBox 47"/>
+          <p:cNvSpPr txBox="1"/>
+          <p:nvPr/>
+        </p:nvSpPr>
+        <p:spPr>
+          <a:xfrm>
+            <a:off x="8631936" y="3346704"/>
+            <a:ext cx="914400" cy="384048"/>
+          </a:xfrm>
+          <a:prstGeom prst="rect">
+            <a:avLst/>
+          </a:prstGeom>
+          <a:noFill/>
+        </p:spPr>
+        <p:txBody>
+          <a:bodyPr wrap="square">
+            <a:spAutoFit/>
+          </a:bodyPr>
+          <a:lstStyle/>
+          <a:p>
+            <a:pPr algn="l"/>
+            <a:r>
+              <a:rPr sz="800" b="0">
+                <a:solidFill>
+                  <a:srgbClr val="2C3E50"/>
+                </a:solidFill>
+              </a:rPr>
+              <a:t>bc48283a</a:t>
+            </a:r>
+          </a:p>
+        </p:txBody>
+      </p:sp>
+      <p:sp>
+        <p:nvSpPr>
+          <p:cNvPr id="49" name="TextBox 48"/>
+          <p:cNvSpPr txBox="1"/>
+          <p:nvPr/>
+        </p:nvSpPr>
+        <p:spPr>
+          <a:xfrm>
+            <a:off x="9546336" y="3346704"/>
+            <a:ext cx="1005840" cy="384048"/>
+          </a:xfrm>
+          <a:prstGeom prst="rect">
+            <a:avLst/>
+          </a:prstGeom>
+          <a:noFill/>
+        </p:spPr>
+        <p:txBody>
+          <a:bodyPr wrap="square">
+            <a:spAutoFit/>
+          </a:bodyPr>
+          <a:lstStyle/>
+          <a:p>
+            <a:pPr algn="l"/>
+            <a:r>
+              <a:rPr sz="800" b="0">
+                <a:solidFill>
+                  <a:srgbClr val="2C3E50"/>
+                </a:solidFill>
+              </a:rPr>
+              <a:t>Ops / Remote</a:t>
+            </a:r>
+          </a:p>
+        </p:txBody>
+      </p:sp>
+      <p:sp>
+        <p:nvSpPr>
+          <p:cNvPr id="50" name="TextBox 49"/>
+          <p:cNvSpPr txBox="1"/>
+          <p:nvPr/>
+        </p:nvSpPr>
+        <p:spPr>
+          <a:xfrm>
+            <a:off x="10552176" y="3346704"/>
+            <a:ext cx="548640" cy="384048"/>
+          </a:xfrm>
+          <a:prstGeom prst="rect">
+            <a:avLst/>
+          </a:prstGeom>
+          <a:noFill/>
+        </p:spPr>
+        <p:txBody>
+          <a:bodyPr wrap="square">
+            <a:spAutoFit/>
+          </a:bodyPr>
+          <a:lstStyle/>
+          <a:p>
+            <a:pPr algn="l"/>
+            <a:r>
+              <a:rPr sz="800" b="0">
+                <a:solidFill>
+                  <a:srgbClr val="2C3E50"/>
+                </a:solidFill>
+              </a:rPr>
+              <a:t> 8</a:t>
+            </a:r>
+          </a:p>
+        </p:txBody>
+      </p:sp>
+      <p:sp>
+        <p:nvSpPr>
+          <p:cNvPr id="51" name="TextBox 50"/>
+          <p:cNvSpPr txBox="1"/>
+          <p:nvPr/>
+        </p:nvSpPr>
+        <p:spPr>
+          <a:xfrm>
+            <a:off x="11100816" y="3346704"/>
+            <a:ext cx="594360" cy="384048"/>
+          </a:xfrm>
+          <a:prstGeom prst="rect">
+            <a:avLst/>
+          </a:prstGeom>
+          <a:noFill/>
+        </p:spPr>
+        <p:txBody>
+          <a:bodyPr wrap="square">
+            <a:spAutoFit/>
+          </a:bodyPr>
+          <a:lstStyle/>
+          <a:p>
+            <a:pPr algn="l"/>
+            <a:r>
+              <a:rPr sz="800" b="0">
+                <a:solidFill>
+                  <a:srgbClr val="2C3E50"/>
+                </a:solidFill>
+              </a:rPr>
+              <a:t>38%</a:t>
+            </a:r>
+          </a:p>
+        </p:txBody>
+      </p:sp>
+      <p:sp>
+        <p:nvSpPr>
+          <p:cNvPr id="52" name="TextBox 51"/>
+          <p:cNvSpPr txBox="1"/>
+          <p:nvPr/>
+        </p:nvSpPr>
+        <p:spPr>
+          <a:xfrm>
+            <a:off x="11695176" y="3346704"/>
+            <a:ext cx="594360" cy="384048"/>
+          </a:xfrm>
+          <a:prstGeom prst="rect">
+            <a:avLst/>
+          </a:prstGeom>
+          <a:noFill/>
+        </p:spPr>
+        <p:txBody>
+          <a:bodyPr wrap="square">
+            <a:spAutoFit/>
+          </a:bodyPr>
+          <a:lstStyle/>
+          <a:p>
+            <a:pPr algn="l"/>
+            <a:r>
+              <a:rPr sz="800" b="0">
+                <a:solidFill>
+                  <a:srgbClr val="2C3E50"/>
+                </a:solidFill>
+              </a:rPr>
+              <a:t>6.9</a:t>
+            </a:r>
+          </a:p>
+        </p:txBody>
+      </p:sp>
+      <p:sp>
+        <p:nvSpPr>
+          <p:cNvPr id="53" name="TextBox 52"/>
+          <p:cNvSpPr txBox="1"/>
+          <p:nvPr/>
+        </p:nvSpPr>
+        <p:spPr>
+          <a:xfrm>
+            <a:off x="12289536" y="3346704"/>
+            <a:ext cx="1417320" cy="384048"/>
+          </a:xfrm>
+          <a:prstGeom prst="rect">
+            <a:avLst/>
+          </a:prstGeom>
+          <a:noFill/>
+        </p:spPr>
+        <p:txBody>
+          <a:bodyPr wrap="square">
+            <a:spAutoFit/>
+          </a:bodyPr>
+          <a:lstStyle/>
+          <a:p>
+            <a:pPr algn="l"/>
+            <a:r>
+              <a:rPr sz="800" b="0">
+                <a:solidFill>
+                  <a:srgbClr val="2C3E50"/>
+                </a:solidFill>
+              </a:rPr>
+              <a:t>Early exits (3mo)</a:t>
+            </a:r>
+          </a:p>
+        </p:txBody>
+      </p:sp>
+      <p:sp>
+        <p:nvSpPr>
+          <p:cNvPr id="54" name="TextBox 53"/>
+          <p:cNvSpPr txBox="1"/>
+          <p:nvPr/>
+        </p:nvSpPr>
+        <p:spPr>
+          <a:xfrm>
+            <a:off x="13706856" y="3346704"/>
+            <a:ext cx="777240" cy="384048"/>
+          </a:xfrm>
+          <a:prstGeom prst="rect">
+            <a:avLst/>
+          </a:prstGeom>
+          <a:noFill/>
+        </p:spPr>
+        <p:txBody>
+          <a:bodyPr wrap="square">
+            <a:spAutoFit/>
+          </a:bodyPr>
+          <a:lstStyle/>
+          <a:p>
+            <a:pPr algn="l"/>
+            <a:r>
+              <a:rPr sz="800" b="1">
+                <a:solidFill>
+                  <a:srgbClr val="E67E22"/>
+                </a:solidFill>
+              </a:rPr>
+              <a:t>WATCH</a:t>
+            </a:r>
+          </a:p>
+        </p:txBody>
+      </p:sp>
+      <p:sp>
+        <p:nvSpPr>
+          <p:cNvPr id="55" name="TextBox 54"/>
+          <p:cNvSpPr txBox="1"/>
+          <p:nvPr/>
+        </p:nvSpPr>
+        <p:spPr>
+          <a:xfrm>
+            <a:off x="8595360" y="5394960"/>
+            <a:ext cx="3383280" cy="822960"/>
+          </a:xfrm>
+          <a:prstGeom prst="rect">
+            <a:avLst/>
+          </a:prstGeom>
+          <a:noFill/>
+        </p:spPr>
+        <p:txBody>
+          <a:bodyPr wrap="square">
+            <a:spAutoFit/>
+          </a:bodyPr>
+          <a:lstStyle/>
+          <a:p>
+            <a:pPr algn="l"/>
+            <a:r>
+              <a:rPr sz="900" b="0">
+                <a:solidFill>
+                  <a:srgbClr val="2C3E50"/>
+                </a:solidFill>
+              </a:rPr>
+              <a:t>Action: structured skip-level conversations for both PRIORITY managers within 30 days. Use existing manager-effectiveness scores as the evidence base — the data is already there.</a:t>
             </a:r>
           </a:p>
         </p:txBody>

</xml_diff>